<commit_message>
Update InfraGuard demo and workflow
</commit_message>
<xml_diff>
--- a/InfraGuard-pitch.pptx
+++ b/InfraGuard-pitch.pptx
@@ -122,518 +122,6 @@
 </p:presentation>
 </file>
 
-<file path=ppt/charts/chart1.xml><?xml version="1.0" encoding="utf-8"?>
-<c:chartSpace xmlns:c="http://schemas.openxmlformats.org/drawingml/2006/chart" xmlns:a="http://schemas.openxmlformats.org/drawingml/2006/main" xmlns:r="http://schemas.openxmlformats.org/officeDocument/2006/relationships" xmlns:c16r2="http://schemas.microsoft.com/office/drawing/2015/06/chart">
-  <c:date1904 val="0"/>
-  <c:lang val="en-US"/>
-  <c:roundedCorners val="1"/>
-  <c:style val="2"/>
-  <c:chart>
-    <c:title>
-      <c:tx>
-        <c:rich>
-          <a:bodyPr/>
-          <a:lstStyle/>
-          <a:p>
-            <a:pPr>
-              <a:defRPr sz="1100" b="0" i="0" u="none" strike="noStrike">
-                <a:solidFill>
-                  <a:srgbClr val="F2F6FC"/>
-                </a:solidFill>
-                <a:latin typeface="Calibri"/>
-              </a:defRPr>
-            </a:pPr>
-            <a:r>
-              <a:rPr lang="en-GB" sz="1100" b="0" i="0" u="none" strike="noStrike">
-                <a:solidFill>
-                  <a:srgbClr val="F2F6FC"/>
-                </a:solidFill>
-                <a:latin typeface="Calibri"/>
-              </a:rPr>
-              <a:t>Cumulative net benefit (₹ lakh) by month</a:t>
-            </a:r>
-          </a:p>
-        </c:rich>
-      </c:tx>
-      <c:overlay val="0"/>
-    </c:title>
-    <c:autoTitleDeleted val="0"/>
-    <c:plotArea>
-      <c:layout/>
-      <c:lineChart>
-        <c:grouping val="standard"/>
-        <c:varyColors val="0"/>
-        <c:ser>
-          <c:idx val="0"/>
-          <c:order val="0"/>
-          <c:tx>
-            <c:strRef>
-              <c:f>Sheet1!$B$1</c:f>
-              <c:strCache>
-                <c:ptCount val="1"/>
-                <c:pt idx="0">
-                  <c:v>Conservative</c:v>
-                </c:pt>
-              </c:strCache>
-            </c:strRef>
-          </c:tx>
-          <c:spPr>
-            <a:ln w="31750" cap="flat">
-              <a:solidFill>
-                <a:srgbClr val="5B9DFF"/>
-              </a:solidFill>
-              <a:prstDash val="solid"/>
-              <a:round/>
-            </a:ln>
-            <a:effectLst/>
-          </c:spPr>
-          <c:marker>
-            <c:symbol val="circle"/>
-            <c:size val="5"/>
-            <c:spPr>
-              <a:solidFill>
-                <a:srgbClr val="5B9DFF"/>
-              </a:solidFill>
-              <a:ln w="9525" cap="flat">
-                <a:solidFill>
-                  <a:srgbClr val="5B9DFF"/>
-                </a:solidFill>
-                <a:prstDash val="solid"/>
-                <a:round/>
-              </a:ln>
-              <a:effectLst/>
-            </c:spPr>
-          </c:marker>
-          <c:cat>
-            <c:strRef>
-              <c:f>Sheet1!$A$2:$A$8</c:f>
-              <c:strCache>
-                <c:ptCount val="7"/>
-                <c:pt idx="0">
-                  <c:v>0</c:v>
-                </c:pt>
-                <c:pt idx="1">
-                  <c:v>6</c:v>
-                </c:pt>
-                <c:pt idx="2">
-                  <c:v>12</c:v>
-                </c:pt>
-                <c:pt idx="3">
-                  <c:v>18</c:v>
-                </c:pt>
-                <c:pt idx="4">
-                  <c:v>24</c:v>
-                </c:pt>
-                <c:pt idx="5">
-                  <c:v>30</c:v>
-                </c:pt>
-                <c:pt idx="6">
-                  <c:v>36</c:v>
-                </c:pt>
-              </c:strCache>
-            </c:strRef>
-          </c:cat>
-          <c:val>
-            <c:numRef>
-              <c:f>Sheet1!$B$2:$B$8</c:f>
-              <c:numCache>
-                <c:formatCode>General</c:formatCode>
-                <c:ptCount val="7"/>
-                <c:pt idx="0">
-                  <c:v>-25</c:v>
-                </c:pt>
-                <c:pt idx="1">
-                  <c:v>-16.600000000000001</c:v>
-                </c:pt>
-                <c:pt idx="2">
-                  <c:v>-8.3000000000000007</c:v>
-                </c:pt>
-                <c:pt idx="3">
-                  <c:v>0.1</c:v>
-                </c:pt>
-                <c:pt idx="4">
-                  <c:v>8.4</c:v>
-                </c:pt>
-                <c:pt idx="5">
-                  <c:v>16.8</c:v>
-                </c:pt>
-                <c:pt idx="6">
-                  <c:v>25.1</c:v>
-                </c:pt>
-              </c:numCache>
-            </c:numRef>
-          </c:val>
-          <c:smooth val="0"/>
-          <c:extLst>
-            <c:ext xmlns:c16="http://schemas.microsoft.com/office/drawing/2014/chart" uri="{C3380CC4-5D6E-409C-BE32-E72D297353CC}">
-              <c16:uniqueId val="{00000000-7531-44E0-B2C0-7869A091C7AD}"/>
-            </c:ext>
-          </c:extLst>
-        </c:ser>
-        <c:ser>
-          <c:idx val="1"/>
-          <c:order val="1"/>
-          <c:tx>
-            <c:strRef>
-              <c:f>Sheet1!$C$1</c:f>
-              <c:strCache>
-                <c:ptCount val="1"/>
-                <c:pt idx="0">
-                  <c:v>Base</c:v>
-                </c:pt>
-              </c:strCache>
-            </c:strRef>
-          </c:tx>
-          <c:spPr>
-            <a:ln w="31750" cap="flat">
-              <a:solidFill>
-                <a:srgbClr val="F5A524"/>
-              </a:solidFill>
-              <a:prstDash val="solid"/>
-              <a:round/>
-            </a:ln>
-            <a:effectLst/>
-          </c:spPr>
-          <c:marker>
-            <c:symbol val="circle"/>
-            <c:size val="5"/>
-            <c:spPr>
-              <a:solidFill>
-                <a:srgbClr val="F5A524"/>
-              </a:solidFill>
-              <a:ln w="9525" cap="flat">
-                <a:solidFill>
-                  <a:srgbClr val="F5A524"/>
-                </a:solidFill>
-                <a:prstDash val="solid"/>
-                <a:round/>
-              </a:ln>
-              <a:effectLst/>
-            </c:spPr>
-          </c:marker>
-          <c:cat>
-            <c:strRef>
-              <c:f>Sheet1!$A$2:$A$8</c:f>
-              <c:strCache>
-                <c:ptCount val="7"/>
-                <c:pt idx="0">
-                  <c:v>0</c:v>
-                </c:pt>
-                <c:pt idx="1">
-                  <c:v>6</c:v>
-                </c:pt>
-                <c:pt idx="2">
-                  <c:v>12</c:v>
-                </c:pt>
-                <c:pt idx="3">
-                  <c:v>18</c:v>
-                </c:pt>
-                <c:pt idx="4">
-                  <c:v>24</c:v>
-                </c:pt>
-                <c:pt idx="5">
-                  <c:v>30</c:v>
-                </c:pt>
-                <c:pt idx="6">
-                  <c:v>36</c:v>
-                </c:pt>
-              </c:strCache>
-            </c:strRef>
-          </c:cat>
-          <c:val>
-            <c:numRef>
-              <c:f>Sheet1!$C$2:$C$8</c:f>
-              <c:numCache>
-                <c:formatCode>General</c:formatCode>
-                <c:ptCount val="7"/>
-                <c:pt idx="0">
-                  <c:v>-25</c:v>
-                </c:pt>
-                <c:pt idx="1">
-                  <c:v>1.7</c:v>
-                </c:pt>
-                <c:pt idx="2">
-                  <c:v>28.4</c:v>
-                </c:pt>
-                <c:pt idx="3">
-                  <c:v>55.1</c:v>
-                </c:pt>
-                <c:pt idx="4">
-                  <c:v>81.8</c:v>
-                </c:pt>
-                <c:pt idx="5">
-                  <c:v>108.5</c:v>
-                </c:pt>
-                <c:pt idx="6">
-                  <c:v>135.19999999999999</c:v>
-                </c:pt>
-              </c:numCache>
-            </c:numRef>
-          </c:val>
-          <c:smooth val="0"/>
-          <c:extLst>
-            <c:ext xmlns:c16="http://schemas.microsoft.com/office/drawing/2014/chart" uri="{C3380CC4-5D6E-409C-BE32-E72D297353CC}">
-              <c16:uniqueId val="{00000001-7531-44E0-B2C0-7869A091C7AD}"/>
-            </c:ext>
-          </c:extLst>
-        </c:ser>
-        <c:ser>
-          <c:idx val="2"/>
-          <c:order val="2"/>
-          <c:tx>
-            <c:strRef>
-              <c:f>Sheet1!$D$1</c:f>
-              <c:strCache>
-                <c:ptCount val="1"/>
-                <c:pt idx="0">
-                  <c:v>Optimistic</c:v>
-                </c:pt>
-              </c:strCache>
-            </c:strRef>
-          </c:tx>
-          <c:spPr>
-            <a:ln w="31750" cap="flat">
-              <a:solidFill>
-                <a:srgbClr val="34D3B4"/>
-              </a:solidFill>
-              <a:prstDash val="solid"/>
-              <a:round/>
-            </a:ln>
-            <a:effectLst/>
-          </c:spPr>
-          <c:marker>
-            <c:symbol val="circle"/>
-            <c:size val="5"/>
-            <c:spPr>
-              <a:solidFill>
-                <a:srgbClr val="34D3B4"/>
-              </a:solidFill>
-              <a:ln w="9525" cap="flat">
-                <a:solidFill>
-                  <a:srgbClr val="34D3B4"/>
-                </a:solidFill>
-                <a:prstDash val="solid"/>
-                <a:round/>
-              </a:ln>
-              <a:effectLst/>
-            </c:spPr>
-          </c:marker>
-          <c:cat>
-            <c:strRef>
-              <c:f>Sheet1!$A$2:$A$8</c:f>
-              <c:strCache>
-                <c:ptCount val="7"/>
-                <c:pt idx="0">
-                  <c:v>0</c:v>
-                </c:pt>
-                <c:pt idx="1">
-                  <c:v>6</c:v>
-                </c:pt>
-                <c:pt idx="2">
-                  <c:v>12</c:v>
-                </c:pt>
-                <c:pt idx="3">
-                  <c:v>18</c:v>
-                </c:pt>
-                <c:pt idx="4">
-                  <c:v>24</c:v>
-                </c:pt>
-                <c:pt idx="5">
-                  <c:v>30</c:v>
-                </c:pt>
-                <c:pt idx="6">
-                  <c:v>36</c:v>
-                </c:pt>
-              </c:strCache>
-            </c:strRef>
-          </c:cat>
-          <c:val>
-            <c:numRef>
-              <c:f>Sheet1!$D$2:$D$8</c:f>
-              <c:numCache>
-                <c:formatCode>General</c:formatCode>
-                <c:ptCount val="7"/>
-                <c:pt idx="0">
-                  <c:v>-25</c:v>
-                </c:pt>
-                <c:pt idx="1">
-                  <c:v>12.6</c:v>
-                </c:pt>
-                <c:pt idx="2">
-                  <c:v>50.2</c:v>
-                </c:pt>
-                <c:pt idx="3">
-                  <c:v>87.7</c:v>
-                </c:pt>
-                <c:pt idx="4">
-                  <c:v>125.3</c:v>
-                </c:pt>
-                <c:pt idx="5">
-                  <c:v>162.9</c:v>
-                </c:pt>
-                <c:pt idx="6">
-                  <c:v>200.5</c:v>
-                </c:pt>
-              </c:numCache>
-            </c:numRef>
-          </c:val>
-          <c:smooth val="0"/>
-          <c:extLst>
-            <c:ext xmlns:c16="http://schemas.microsoft.com/office/drawing/2014/chart" uri="{C3380CC4-5D6E-409C-BE32-E72D297353CC}">
-              <c16:uniqueId val="{00000002-7531-44E0-B2C0-7869A091C7AD}"/>
-            </c:ext>
-          </c:extLst>
-        </c:ser>
-        <c:dLbls>
-          <c:showLegendKey val="0"/>
-          <c:showVal val="0"/>
-          <c:showCatName val="0"/>
-          <c:showSerName val="0"/>
-          <c:showPercent val="0"/>
-          <c:showBubbleSize val="0"/>
-        </c:dLbls>
-        <c:marker val="1"/>
-        <c:smooth val="0"/>
-        <c:axId val="2094734554"/>
-        <c:axId val="2094734552"/>
-      </c:lineChart>
-      <c:catAx>
-        <c:axId val="2094734554"/>
-        <c:scaling>
-          <c:orientation val="minMax"/>
-        </c:scaling>
-        <c:delete val="0"/>
-        <c:axPos val="b"/>
-        <c:numFmt formatCode="General" sourceLinked="1"/>
-        <c:majorTickMark val="out"/>
-        <c:minorTickMark val="none"/>
-        <c:tickLblPos val="low"/>
-        <c:spPr>
-          <a:ln w="12700" cap="flat">
-            <a:solidFill>
-              <a:srgbClr val="888888"/>
-            </a:solidFill>
-            <a:prstDash val="solid"/>
-            <a:round/>
-          </a:ln>
-        </c:spPr>
-        <c:txPr>
-          <a:bodyPr/>
-          <a:lstStyle/>
-          <a:p>
-            <a:pPr>
-              <a:defRPr sz="1000" b="0" i="0" u="none" strike="noStrike">
-                <a:solidFill>
-                  <a:srgbClr val="A9BAD0"/>
-                </a:solidFill>
-                <a:latin typeface="Calibri"/>
-              </a:defRPr>
-            </a:pPr>
-            <a:endParaRPr lang="en-US"/>
-          </a:p>
-        </c:txPr>
-        <c:crossAx val="2094734552"/>
-        <c:crosses val="autoZero"/>
-        <c:auto val="1"/>
-        <c:lblAlgn val="ctr"/>
-        <c:lblOffset val="100"/>
-        <c:noMultiLvlLbl val="1"/>
-      </c:catAx>
-      <c:valAx>
-        <c:axId val="2094734552"/>
-        <c:scaling>
-          <c:orientation val="minMax"/>
-        </c:scaling>
-        <c:delete val="0"/>
-        <c:axPos val="l"/>
-        <c:majorGridlines>
-          <c:spPr>
-            <a:ln w="6350" cap="flat">
-              <a:solidFill>
-                <a:srgbClr val="2A4466"/>
-              </a:solidFill>
-              <a:prstDash val="solid"/>
-              <a:round/>
-            </a:ln>
-          </c:spPr>
-        </c:majorGridlines>
-        <c:numFmt formatCode="0" sourceLinked="0"/>
-        <c:majorTickMark val="out"/>
-        <c:minorTickMark val="none"/>
-        <c:tickLblPos val="nextTo"/>
-        <c:spPr>
-          <a:ln w="12700" cap="flat">
-            <a:solidFill>
-              <a:srgbClr val="888888"/>
-            </a:solidFill>
-            <a:prstDash val="solid"/>
-            <a:round/>
-          </a:ln>
-        </c:spPr>
-        <c:txPr>
-          <a:bodyPr/>
-          <a:lstStyle/>
-          <a:p>
-            <a:pPr>
-              <a:defRPr sz="1000" b="0" i="0" u="none" strike="noStrike">
-                <a:solidFill>
-                  <a:srgbClr val="A9BAD0"/>
-                </a:solidFill>
-                <a:latin typeface="Calibri"/>
-              </a:defRPr>
-            </a:pPr>
-            <a:endParaRPr lang="en-US"/>
-          </a:p>
-        </c:txPr>
-        <c:crossAx val="2094734554"/>
-        <c:crosses val="autoZero"/>
-        <c:crossBetween val="between"/>
-      </c:valAx>
-      <c:spPr>
-        <a:noFill/>
-        <a:ln>
-          <a:noFill/>
-        </a:ln>
-        <a:effectLst/>
-      </c:spPr>
-    </c:plotArea>
-    <c:legend>
-      <c:legendPos val="b"/>
-      <c:overlay val="0"/>
-      <c:txPr>
-        <a:bodyPr/>
-        <a:lstStyle/>
-        <a:p>
-          <a:pPr>
-            <a:defRPr sz="1000">
-              <a:solidFill>
-                <a:srgbClr val="A9BAD0"/>
-              </a:solidFill>
-              <a:latin typeface="Calibri"/>
-              <a:cs typeface="Calibri"/>
-            </a:defRPr>
-          </a:pPr>
-          <a:endParaRPr lang="en-US"/>
-        </a:p>
-      </c:txPr>
-    </c:legend>
-    <c:plotVisOnly val="1"/>
-    <c:dispBlanksAs val="span"/>
-    <c:showDLblsOverMax val="1"/>
-  </c:chart>
-  <c:spPr>
-    <a:noFill/>
-    <a:ln>
-      <a:noFill/>
-    </a:ln>
-    <a:effectLst/>
-  </c:spPr>
-  <c:externalData r:id="rId1">
-    <c:autoUpdate val="0"/>
-  </c:externalData>
-</c:chartSpace>
-</file>
-
 <file path=ppt/notesMasters/notesMaster1.xml><?xml version="1.0" encoding="utf-8"?>
 <p:notesMaster xmlns:a="http://schemas.openxmlformats.org/drawingml/2006/main" xmlns:r="http://schemas.openxmlformats.org/officeDocument/2006/relationships" xmlns:p="http://schemas.openxmlformats.org/presentationml/2006/main">
   <p:cSld>
@@ -659,7 +147,7 @@
     </p:spTree>
     <p:extLst>
       <p:ext uri="{BB962C8B-B14F-4D97-AF65-F5344CB8AC3E}">
-        <p14:creationId xmlns:p14="http://schemas.microsoft.com/office/powerpoint/2010/main" val="1773344343"/>
+        <p14:creationId xmlns:p14="http://schemas.microsoft.com/office/powerpoint/2010/main" val="2195400830"/>
       </p:ext>
     </p:extLst>
   </p:cSld>
@@ -1675,7 +1163,7 @@
           <a:p>
             <a:r>
               <a:rPr lang="en-US" dirty="0"/>
-              <a:t>Every figure comes from the stated assumptions; change an assumption and the numbers change. Break-even logic: the system pays for itself if it avoids a modest share of the modelled closure-hours and callouts. A pilot replaces these inputs with the operator's own data.</a:t>
+              <a:t>Show the Business Impact page. Per incident: engineer effort 9h to 3h. Per year: 211 lakh to 138 lakh for a 10-structure network. Say 'illustrative' out loud; time to flag is the only measured number.</a:t>
             </a:r>
           </a:p>
         </p:txBody>
@@ -2331,10 +1819,21 @@
                 <a:ea typeface="Calibri" pitchFamily="34" charset="-122"/>
                 <a:cs typeface="Calibri" pitchFamily="34" charset="-120"/>
               </a:rPr>
-              <a:t>AGENTOPS HACKATHON  ·  MIT BENGALURU  ·  TEAM AKINATORS</a:t>
+              <a:t>AGENTOPS HACKATHON  ·  MIT BENGALURU  ·  </a:t>
+            </a:r>
+            <a:r>
+              <a:rPr lang="en-US" sz="1100" b="1" kern="0" spc="200">
+                <a:solidFill>
+                  <a:srgbClr val="F5A524"/>
+                </a:solidFill>
+                <a:latin typeface="Calibri" pitchFamily="34" charset="0"/>
+                <a:ea typeface="Calibri" pitchFamily="34" charset="-122"/>
+                <a:cs typeface="Calibri" pitchFamily="34" charset="-120"/>
+              </a:rPr>
+              <a:t>TEAM AKINATORS</a:t>
             </a:r>
             <a:br>
-              <a:rPr lang="en-US" sz="1100" b="1" kern="0" spc="200" dirty="0">
+              <a:rPr lang="en-US" sz="1100" b="1" kern="0" spc="200">
                 <a:solidFill>
                   <a:srgbClr val="F5A524"/>
                 </a:solidFill>
@@ -2344,7 +1843,7 @@
               </a:rPr>
             </a:br>
             <a:r>
-              <a:rPr lang="en-US" sz="1100" b="1" kern="0" spc="200" dirty="0">
+              <a:rPr lang="en-US" sz="1100" b="1" kern="0" spc="200">
                 <a:solidFill>
                   <a:srgbClr val="F5A524"/>
                 </a:solidFill>
@@ -2352,8 +1851,13 @@
                 <a:ea typeface="Calibri" pitchFamily="34" charset="-122"/>
                 <a:cs typeface="Calibri" pitchFamily="34" charset="-120"/>
               </a:rPr>
-              <a:t>DOMAIN : TRANSPORT</a:t>
-            </a:r>
+              <a:t>TRANSPORT</a:t>
+            </a:r>
+          </a:p>
+          <a:p>
+            <a:pPr marL="0" indent="0">
+              <a:buNone/>
+            </a:pPr>
             <a:endParaRPr lang="en-US" sz="1100" dirty="0"/>
           </a:p>
         </p:txBody>
@@ -3100,7 +2604,7 @@
                 <a:ea typeface="Calibri" pitchFamily="34" charset="-122"/>
                 <a:cs typeface="Calibri" pitchFamily="34" charset="-120"/>
               </a:rPr>
-              <a:t>Runs offline end to end; 70 tests and a 119-check browser journey; state, files and audit survive a restart</a:t>
+              <a:t>Runs offline end to end; 70 tests and a 126-check browser journey; state, files and audit survive a restart</a:t>
             </a:r>
             <a:endParaRPr lang="en-US" sz="1200" dirty="0"/>
           </a:p>
@@ -3495,7 +2999,7 @@
                 <a:ea typeface="Calibri" pitchFamily="34" charset="-122"/>
                 <a:cs typeface="Calibri" pitchFamily="34" charset="-120"/>
               </a:rPr>
-              <a:t>Versioned reports and read-only audit trail</a:t>
+              <a:t>Versioned reports, audit trail, Business Impact page</a:t>
             </a:r>
             <a:endParaRPr lang="en-US" sz="1300" dirty="0"/>
           </a:p>
@@ -3537,7 +3041,7 @@
                 <a:ea typeface="Calibri" pitchFamily="34" charset="-122"/>
                 <a:cs typeface="Calibri" pitchFamily="34" charset="-120"/>
               </a:rPr>
-              <a:t>70 backend tests, 119-check browser journey</a:t>
+              <a:t>70 backend tests, 126-check browser journey</a:t>
             </a:r>
             <a:endParaRPr lang="en-US" sz="1300" dirty="0"/>
           </a:p>
@@ -10213,7 +9717,7 @@
                 <a:ea typeface="Calibri" pitchFamily="34" charset="-122"/>
                 <a:cs typeface="Calibri" pitchFamily="34" charset="-120"/>
               </a:rPr>
-              <a:t>Illustrative impact: time and money, with every assumption stated</a:t>
+              <a:t>Usual process vs InfraGuard: time and money, live in the product</a:t>
             </a:r>
             <a:endParaRPr lang="en-US" sz="2600" dirty="0"/>
           </a:p>
@@ -10227,12 +9731,556 @@
         </p:nvSpPr>
         <p:spPr>
           <a:xfrm>
-            <a:off x="457200" y="1188720"/>
-            <a:ext cx="1965960" cy="914400"/>
+            <a:off x="420624" y="1197864"/>
+            <a:ext cx="4919472" cy="3043477"/>
+          </a:xfrm>
+          <a:prstGeom prst="rect">
+            <a:avLst/>
+          </a:prstGeom>
+          <a:solidFill>
+            <a:srgbClr val="2A4466"/>
+          </a:solidFill>
+          <a:ln w="6350">
+            <a:solidFill>
+              <a:srgbClr val="2A4466"/>
+            </a:solidFill>
+            <a:prstDash val="solid"/>
+          </a:ln>
+        </p:spPr>
+      </p:sp>
+      <p:pic>
+        <p:nvPicPr>
+          <p:cNvPr id="4" name="Image 0" descr="C:/Users/Dell/Desktop/InfraGuard/docs/screenshots/business-impact-year.png"/>
+          <p:cNvPicPr>
+            <a:picLocks noChangeAspect="1"/>
+          </p:cNvPicPr>
+          <p:nvPr/>
+        </p:nvPicPr>
+        <p:blipFill>
+          <a:blip r:embed="rId3"/>
+          <a:stretch>
+            <a:fillRect/>
+          </a:stretch>
+        </p:blipFill>
+        <p:spPr>
+          <a:xfrm>
+            <a:off x="457200" y="1234440"/>
+            <a:ext cx="4846320" cy="2970325"/>
+          </a:xfrm>
+          <a:prstGeom prst="rect">
+            <a:avLst/>
+          </a:prstGeom>
+        </p:spPr>
+      </p:pic>
+      <p:sp>
+        <p:nvSpPr>
+          <p:cNvPr id="5" name="Text 2"/>
+          <p:cNvSpPr txBox="1"/>
+          <p:nvPr/>
+        </p:nvSpPr>
+        <p:spPr>
+          <a:xfrm>
+            <a:off x="457200" y="4314493"/>
+            <a:ext cx="4846320" cy="228600"/>
+          </a:xfrm>
+          <a:prstGeom prst="rect">
+            <a:avLst/>
+          </a:prstGeom>
+          <a:noFill/>
+          <a:ln/>
+        </p:spPr>
+        <p:txBody>
+          <a:bodyPr wrap="square" lIns="0" tIns="0" rIns="0" bIns="0" rtlCol="0" anchor="t"/>
+          <a:lstStyle/>
+          <a:p>
+            <a:pPr marL="0" indent="0">
+              <a:buNone/>
+            </a:pPr>
+            <a:r>
+              <a:rPr lang="en-US" sz="1100" dirty="0">
+                <a:solidFill>
+                  <a:srgbClr val="A9BAD0"/>
+                </a:solidFill>
+                <a:latin typeface="Calibri" pitchFamily="34" charset="0"/>
+                <a:ea typeface="Calibri" pitchFamily="34" charset="-122"/>
+                <a:cs typeface="Calibri" pitchFamily="34" charset="-120"/>
+              </a:rPr>
+              <a:t>Business Impact page in the prototype (illustrative model)</a:t>
+            </a:r>
+            <a:endParaRPr lang="en-US" sz="1100" dirty="0"/>
+          </a:p>
+        </p:txBody>
+      </p:sp>
+      <p:sp>
+        <p:nvSpPr>
+          <p:cNvPr id="6" name="Shape 3"/>
+          <p:cNvSpPr/>
+          <p:nvPr/>
+        </p:nvSpPr>
+        <p:spPr>
+          <a:xfrm>
+            <a:off x="5532120" y="1188720"/>
+            <a:ext cx="3154680" cy="1920240"/>
           </a:xfrm>
           <a:prstGeom prst="roundRect">
             <a:avLst>
-              <a:gd name="adj" fmla="val 8000"/>
+              <a:gd name="adj" fmla="val 3810"/>
+            </a:avLst>
+          </a:prstGeom>
+          <a:solidFill>
+            <a:srgbClr val="13243B"/>
+          </a:solidFill>
+          <a:ln w="9525">
+            <a:solidFill>
+              <a:srgbClr val="2A4466"/>
+            </a:solidFill>
+            <a:prstDash val="solid"/>
+          </a:ln>
+        </p:spPr>
+      </p:sp>
+      <p:sp>
+        <p:nvSpPr>
+          <p:cNvPr id="7" name="Text 4"/>
+          <p:cNvSpPr txBox="1"/>
+          <p:nvPr/>
+        </p:nvSpPr>
+        <p:spPr>
+          <a:xfrm>
+            <a:off x="5669280" y="1261872"/>
+            <a:ext cx="2926080" cy="201168"/>
+          </a:xfrm>
+          <a:prstGeom prst="rect">
+            <a:avLst/>
+          </a:prstGeom>
+          <a:noFill/>
+          <a:ln/>
+        </p:spPr>
+        <p:txBody>
+          <a:bodyPr wrap="square" lIns="0" tIns="0" rIns="0" bIns="0" rtlCol="0" anchor="t"/>
+          <a:lstStyle/>
+          <a:p>
+            <a:pPr marL="0" indent="0">
+              <a:buNone/>
+            </a:pPr>
+            <a:r>
+              <a:rPr lang="en-US" sz="1000" b="1" kern="0" spc="100" dirty="0">
+                <a:solidFill>
+                  <a:srgbClr val="F5A524"/>
+                </a:solidFill>
+                <a:latin typeface="Calibri" pitchFamily="34" charset="0"/>
+                <a:ea typeface="Calibri" pitchFamily="34" charset="-122"/>
+                <a:cs typeface="Calibri" pitchFamily="34" charset="-120"/>
+              </a:rPr>
+              <a:t>PER REAL INCIDENT</a:t>
+            </a:r>
+            <a:endParaRPr lang="en-US" sz="1000" dirty="0"/>
+          </a:p>
+        </p:txBody>
+      </p:sp>
+      <p:sp>
+        <p:nvSpPr>
+          <p:cNvPr id="8" name="Text 5"/>
+          <p:cNvSpPr txBox="1"/>
+          <p:nvPr/>
+        </p:nvSpPr>
+        <p:spPr>
+          <a:xfrm>
+            <a:off x="5669280" y="1517904"/>
+            <a:ext cx="1280160" cy="274320"/>
+          </a:xfrm>
+          <a:prstGeom prst="rect">
+            <a:avLst/>
+          </a:prstGeom>
+          <a:noFill/>
+          <a:ln/>
+        </p:spPr>
+        <p:txBody>
+          <a:bodyPr wrap="square" lIns="0" tIns="0" rIns="0" bIns="0" rtlCol="0" anchor="ctr"/>
+          <a:lstStyle/>
+          <a:p>
+            <a:pPr marL="0" indent="0">
+              <a:buNone/>
+            </a:pPr>
+            <a:r>
+              <a:rPr lang="en-US" sz="1200" dirty="0">
+                <a:solidFill>
+                  <a:srgbClr val="A9BAD0"/>
+                </a:solidFill>
+                <a:latin typeface="Calibri" pitchFamily="34" charset="0"/>
+                <a:ea typeface="Calibri" pitchFamily="34" charset="-122"/>
+                <a:cs typeface="Calibri" pitchFamily="34" charset="-120"/>
+              </a:rPr>
+              <a:t>Engineer effort</a:t>
+            </a:r>
+            <a:endParaRPr lang="en-US" sz="1200" dirty="0"/>
+          </a:p>
+        </p:txBody>
+      </p:sp>
+      <p:sp>
+        <p:nvSpPr>
+          <p:cNvPr id="9" name="Text 6"/>
+          <p:cNvSpPr txBox="1"/>
+          <p:nvPr/>
+        </p:nvSpPr>
+        <p:spPr>
+          <a:xfrm>
+            <a:off x="6858000" y="1517904"/>
+            <a:ext cx="1737360" cy="274320"/>
+          </a:xfrm>
+          <a:prstGeom prst="rect">
+            <a:avLst/>
+          </a:prstGeom>
+          <a:noFill/>
+          <a:ln/>
+        </p:spPr>
+        <p:txBody>
+          <a:bodyPr wrap="square" lIns="0" tIns="0" rIns="0" bIns="0" rtlCol="0" anchor="ctr"/>
+          <a:lstStyle/>
+          <a:p>
+            <a:pPr marL="0" indent="0" algn="r">
+              <a:buNone/>
+            </a:pPr>
+            <a:r>
+              <a:rPr lang="en-US" sz="1250" b="1" dirty="0">
+                <a:solidFill>
+                  <a:srgbClr val="F2F6FC"/>
+                </a:solidFill>
+                <a:latin typeface="Calibri" pitchFamily="34" charset="0"/>
+                <a:ea typeface="Calibri" pitchFamily="34" charset="-122"/>
+                <a:cs typeface="Calibri" pitchFamily="34" charset="-120"/>
+              </a:rPr>
+              <a:t>9 h → 3 h</a:t>
+            </a:r>
+            <a:endParaRPr lang="en-US" sz="1250" dirty="0"/>
+          </a:p>
+        </p:txBody>
+      </p:sp>
+      <p:sp>
+        <p:nvSpPr>
+          <p:cNvPr id="10" name="Text 7"/>
+          <p:cNvSpPr txBox="1"/>
+          <p:nvPr/>
+        </p:nvSpPr>
+        <p:spPr>
+          <a:xfrm>
+            <a:off x="5669280" y="1828800"/>
+            <a:ext cx="1280160" cy="274320"/>
+          </a:xfrm>
+          <a:prstGeom prst="rect">
+            <a:avLst/>
+          </a:prstGeom>
+          <a:noFill/>
+          <a:ln/>
+        </p:spPr>
+        <p:txBody>
+          <a:bodyPr wrap="square" lIns="0" tIns="0" rIns="0" bIns="0" rtlCol="0" anchor="ctr"/>
+          <a:lstStyle/>
+          <a:p>
+            <a:pPr marL="0" indent="0">
+              <a:buNone/>
+            </a:pPr>
+            <a:r>
+              <a:rPr lang="en-US" sz="1200" dirty="0">
+                <a:solidFill>
+                  <a:srgbClr val="A9BAD0"/>
+                </a:solidFill>
+                <a:latin typeface="Calibri" pitchFamily="34" charset="0"/>
+                <a:ea typeface="Calibri" pitchFamily="34" charset="-122"/>
+                <a:cs typeface="Calibri" pitchFamily="34" charset="-120"/>
+              </a:rPr>
+              <a:t>Cost</a:t>
+            </a:r>
+            <a:endParaRPr lang="en-US" sz="1200" dirty="0"/>
+          </a:p>
+        </p:txBody>
+      </p:sp>
+      <p:sp>
+        <p:nvSpPr>
+          <p:cNvPr id="11" name="Text 8"/>
+          <p:cNvSpPr txBox="1"/>
+          <p:nvPr/>
+        </p:nvSpPr>
+        <p:spPr>
+          <a:xfrm>
+            <a:off x="6858000" y="1828800"/>
+            <a:ext cx="1737360" cy="274320"/>
+          </a:xfrm>
+          <a:prstGeom prst="rect">
+            <a:avLst/>
+          </a:prstGeom>
+          <a:noFill/>
+          <a:ln/>
+        </p:spPr>
+        <p:txBody>
+          <a:bodyPr wrap="square" lIns="0" tIns="0" rIns="0" bIns="0" rtlCol="0" anchor="ctr"/>
+          <a:lstStyle/>
+          <a:p>
+            <a:pPr marL="0" indent="0" algn="r">
+              <a:buNone/>
+            </a:pPr>
+            <a:r>
+              <a:rPr lang="en-US" sz="1250" b="1" dirty="0">
+                <a:solidFill>
+                  <a:srgbClr val="F2F6FC"/>
+                </a:solidFill>
+                <a:latin typeface="Calibri" pitchFamily="34" charset="0"/>
+                <a:ea typeface="Calibri" pitchFamily="34" charset="-122"/>
+                <a:cs typeface="Calibri" pitchFamily="34" charset="-120"/>
+              </a:rPr>
+              <a:t>₹13,500 → ₹4,500</a:t>
+            </a:r>
+            <a:endParaRPr lang="en-US" sz="1250" dirty="0"/>
+          </a:p>
+        </p:txBody>
+      </p:sp>
+      <p:sp>
+        <p:nvSpPr>
+          <p:cNvPr id="12" name="Text 9"/>
+          <p:cNvSpPr txBox="1"/>
+          <p:nvPr/>
+        </p:nvSpPr>
+        <p:spPr>
+          <a:xfrm>
+            <a:off x="5669280" y="2139696"/>
+            <a:ext cx="1280160" cy="274320"/>
+          </a:xfrm>
+          <a:prstGeom prst="rect">
+            <a:avLst/>
+          </a:prstGeom>
+          <a:noFill/>
+          <a:ln/>
+        </p:spPr>
+        <p:txBody>
+          <a:bodyPr wrap="square" lIns="0" tIns="0" rIns="0" bIns="0" rtlCol="0" anchor="ctr"/>
+          <a:lstStyle/>
+          <a:p>
+            <a:pPr marL="0" indent="0">
+              <a:buNone/>
+            </a:pPr>
+            <a:r>
+              <a:rPr lang="en-US" sz="1200" dirty="0">
+                <a:solidFill>
+                  <a:srgbClr val="A9BAD0"/>
+                </a:solidFill>
+                <a:latin typeface="Calibri" pitchFamily="34" charset="0"/>
+                <a:ea typeface="Calibri" pitchFamily="34" charset="-122"/>
+                <a:cs typeface="Calibri" pitchFamily="34" charset="-120"/>
+              </a:rPr>
+              <a:t>Saved</a:t>
+            </a:r>
+            <a:endParaRPr lang="en-US" sz="1200" dirty="0"/>
+          </a:p>
+        </p:txBody>
+      </p:sp>
+      <p:sp>
+        <p:nvSpPr>
+          <p:cNvPr id="13" name="Text 10"/>
+          <p:cNvSpPr txBox="1"/>
+          <p:nvPr/>
+        </p:nvSpPr>
+        <p:spPr>
+          <a:xfrm>
+            <a:off x="6858000" y="2139696"/>
+            <a:ext cx="1737360" cy="274320"/>
+          </a:xfrm>
+          <a:prstGeom prst="rect">
+            <a:avLst/>
+          </a:prstGeom>
+          <a:noFill/>
+          <a:ln/>
+        </p:spPr>
+        <p:txBody>
+          <a:bodyPr wrap="square" lIns="0" tIns="0" rIns="0" bIns="0" rtlCol="0" anchor="ctr"/>
+          <a:lstStyle/>
+          <a:p>
+            <a:pPr marL="0" indent="0" algn="r">
+              <a:buNone/>
+            </a:pPr>
+            <a:r>
+              <a:rPr lang="en-US" sz="1250" b="1" dirty="0">
+                <a:solidFill>
+                  <a:srgbClr val="F5A524"/>
+                </a:solidFill>
+                <a:latin typeface="Calibri" pitchFamily="34" charset="0"/>
+                <a:ea typeface="Calibri" pitchFamily="34" charset="-122"/>
+                <a:cs typeface="Calibri" pitchFamily="34" charset="-120"/>
+              </a:rPr>
+              <a:t>≈ ₹9,000</a:t>
+            </a:r>
+            <a:endParaRPr lang="en-US" sz="1250" dirty="0"/>
+          </a:p>
+        </p:txBody>
+      </p:sp>
+      <p:sp>
+        <p:nvSpPr>
+          <p:cNvPr id="14" name="Text 11"/>
+          <p:cNvSpPr txBox="1"/>
+          <p:nvPr/>
+        </p:nvSpPr>
+        <p:spPr>
+          <a:xfrm>
+            <a:off x="5669280" y="2450592"/>
+            <a:ext cx="1280160" cy="274320"/>
+          </a:xfrm>
+          <a:prstGeom prst="rect">
+            <a:avLst/>
+          </a:prstGeom>
+          <a:noFill/>
+          <a:ln/>
+        </p:spPr>
+        <p:txBody>
+          <a:bodyPr wrap="square" lIns="0" tIns="0" rIns="0" bIns="0" rtlCol="0" anchor="ctr"/>
+          <a:lstStyle/>
+          <a:p>
+            <a:pPr marL="0" indent="0">
+              <a:buNone/>
+            </a:pPr>
+            <a:r>
+              <a:rPr lang="en-US" sz="1200" dirty="0">
+                <a:solidFill>
+                  <a:srgbClr val="A9BAD0"/>
+                </a:solidFill>
+                <a:latin typeface="Calibri" pitchFamily="34" charset="0"/>
+                <a:ea typeface="Calibri" pitchFamily="34" charset="-122"/>
+                <a:cs typeface="Calibri" pitchFamily="34" charset="-120"/>
+              </a:rPr>
+              <a:t>False alarm</a:t>
+            </a:r>
+            <a:endParaRPr lang="en-US" sz="1200" dirty="0"/>
+          </a:p>
+        </p:txBody>
+      </p:sp>
+      <p:sp>
+        <p:nvSpPr>
+          <p:cNvPr id="15" name="Text 12"/>
+          <p:cNvSpPr txBox="1"/>
+          <p:nvPr/>
+        </p:nvSpPr>
+        <p:spPr>
+          <a:xfrm>
+            <a:off x="6858000" y="2450592"/>
+            <a:ext cx="1737360" cy="274320"/>
+          </a:xfrm>
+          <a:prstGeom prst="rect">
+            <a:avLst/>
+          </a:prstGeom>
+          <a:noFill/>
+          <a:ln/>
+        </p:spPr>
+        <p:txBody>
+          <a:bodyPr wrap="square" lIns="0" tIns="0" rIns="0" bIns="0" rtlCol="0" anchor="ctr"/>
+          <a:lstStyle/>
+          <a:p>
+            <a:pPr marL="0" indent="0" algn="r">
+              <a:buNone/>
+            </a:pPr>
+            <a:r>
+              <a:rPr lang="en-US" sz="1250" b="1" dirty="0">
+                <a:solidFill>
+                  <a:srgbClr val="F2F6FC"/>
+                </a:solidFill>
+                <a:latin typeface="Calibri" pitchFamily="34" charset="0"/>
+                <a:ea typeface="Calibri" pitchFamily="34" charset="-122"/>
+                <a:cs typeface="Calibri" pitchFamily="34" charset="-120"/>
+              </a:rPr>
+              <a:t>≈ ₹34,000 → filtered</a:t>
+            </a:r>
+            <a:endParaRPr lang="en-US" sz="1250" dirty="0"/>
+          </a:p>
+        </p:txBody>
+      </p:sp>
+      <p:sp>
+        <p:nvSpPr>
+          <p:cNvPr id="16" name="Text 13"/>
+          <p:cNvSpPr txBox="1"/>
+          <p:nvPr/>
+        </p:nvSpPr>
+        <p:spPr>
+          <a:xfrm>
+            <a:off x="5669280" y="2761488"/>
+            <a:ext cx="1280160" cy="274320"/>
+          </a:xfrm>
+          <a:prstGeom prst="rect">
+            <a:avLst/>
+          </a:prstGeom>
+          <a:noFill/>
+          <a:ln/>
+        </p:spPr>
+        <p:txBody>
+          <a:bodyPr wrap="square" lIns="0" tIns="0" rIns="0" bIns="0" rtlCol="0" anchor="ctr"/>
+          <a:lstStyle/>
+          <a:p>
+            <a:pPr marL="0" indent="0">
+              <a:buNone/>
+            </a:pPr>
+            <a:r>
+              <a:rPr lang="en-US" sz="1200" dirty="0">
+                <a:solidFill>
+                  <a:srgbClr val="A9BAD0"/>
+                </a:solidFill>
+                <a:latin typeface="Calibri" pitchFamily="34" charset="0"/>
+                <a:ea typeface="Calibri" pitchFamily="34" charset="-122"/>
+                <a:cs typeface="Calibri" pitchFamily="34" charset="-120"/>
+              </a:rPr>
+              <a:t>Time to flag</a:t>
+            </a:r>
+            <a:endParaRPr lang="en-US" sz="1200" dirty="0"/>
+          </a:p>
+        </p:txBody>
+      </p:sp>
+      <p:sp>
+        <p:nvSpPr>
+          <p:cNvPr id="17" name="Text 14"/>
+          <p:cNvSpPr txBox="1"/>
+          <p:nvPr/>
+        </p:nvSpPr>
+        <p:spPr>
+          <a:xfrm>
+            <a:off x="6858000" y="2761488"/>
+            <a:ext cx="1737360" cy="274320"/>
+          </a:xfrm>
+          <a:prstGeom prst="rect">
+            <a:avLst/>
+          </a:prstGeom>
+          <a:noFill/>
+          <a:ln/>
+        </p:spPr>
+        <p:txBody>
+          <a:bodyPr wrap="square" lIns="0" tIns="0" rIns="0" bIns="0" rtlCol="0" anchor="ctr"/>
+          <a:lstStyle/>
+          <a:p>
+            <a:pPr marL="0" indent="0" algn="r">
+              <a:buNone/>
+            </a:pPr>
+            <a:r>
+              <a:rPr lang="en-US" sz="1250" b="1" dirty="0">
+                <a:solidFill>
+                  <a:srgbClr val="F2F6FC"/>
+                </a:solidFill>
+                <a:latin typeface="Calibri" pitchFamily="34" charset="0"/>
+                <a:ea typeface="Calibri" pitchFamily="34" charset="-122"/>
+                <a:cs typeface="Calibri" pitchFamily="34" charset="-120"/>
+              </a:rPr>
+              <a:t>45 min (measured)</a:t>
+            </a:r>
+            <a:endParaRPr lang="en-US" sz="1250" dirty="0"/>
+          </a:p>
+        </p:txBody>
+      </p:sp>
+      <p:sp>
+        <p:nvSpPr>
+          <p:cNvPr id="18" name="Shape 15"/>
+          <p:cNvSpPr/>
+          <p:nvPr/>
+        </p:nvSpPr>
+        <p:spPr>
+          <a:xfrm>
+            <a:off x="5532120" y="3246120"/>
+            <a:ext cx="3154680" cy="1234440"/>
+          </a:xfrm>
+          <a:prstGeom prst="roundRect">
+            <a:avLst>
+              <a:gd name="adj" fmla="val 5926"/>
             </a:avLst>
           </a:prstGeom>
           <a:solidFill>
@@ -10248,14 +10296,14 @@
       </p:sp>
       <p:sp>
         <p:nvSpPr>
-          <p:cNvPr id="4" name="Text 2"/>
-          <p:cNvSpPr txBox="1"/>
-          <p:nvPr/>
-        </p:nvSpPr>
-        <p:spPr>
-          <a:xfrm>
-            <a:off x="566928" y="1252728"/>
-            <a:ext cx="1783080" cy="384048"/>
+          <p:cNvPr id="19" name="Text 16"/>
+          <p:cNvSpPr txBox="1"/>
+          <p:nvPr/>
+        </p:nvSpPr>
+        <p:spPr>
+          <a:xfrm>
+            <a:off x="5669280" y="3319272"/>
+            <a:ext cx="2926080" cy="201168"/>
           </a:xfrm>
           <a:prstGeom prst="rect">
             <a:avLst/>
@@ -10271,598 +10319,134 @@
               <a:buNone/>
             </a:pPr>
             <a:r>
+              <a:rPr lang="en-US" sz="1000" b="1" kern="0" spc="100" dirty="0">
+                <a:solidFill>
+                  <a:srgbClr val="F5A524"/>
+                </a:solidFill>
+                <a:latin typeface="Calibri" pitchFamily="34" charset="0"/>
+                <a:ea typeface="Calibri" pitchFamily="34" charset="-122"/>
+                <a:cs typeface="Calibri" pitchFamily="34" charset="-120"/>
+              </a:rPr>
+              <a:t>PER YEAR · 10-STRUCTURE NETWORK</a:t>
+            </a:r>
+            <a:endParaRPr lang="en-US" sz="1000" dirty="0"/>
+          </a:p>
+        </p:txBody>
+      </p:sp>
+      <p:sp>
+        <p:nvSpPr>
+          <p:cNvPr id="20" name="Text 17"/>
+          <p:cNvSpPr txBox="1"/>
+          <p:nvPr/>
+        </p:nvSpPr>
+        <p:spPr>
+          <a:xfrm>
+            <a:off x="5669280" y="3547872"/>
+            <a:ext cx="2926080" cy="365760"/>
+          </a:xfrm>
+          <a:prstGeom prst="rect">
+            <a:avLst/>
+          </a:prstGeom>
+          <a:noFill/>
+          <a:ln/>
+        </p:spPr>
+        <p:txBody>
+          <a:bodyPr wrap="square" lIns="0" tIns="0" rIns="0" bIns="0" rtlCol="0" anchor="t"/>
+          <a:lstStyle/>
+          <a:p>
+            <a:pPr marL="0" indent="0">
+              <a:buNone/>
+            </a:pPr>
+            <a:r>
               <a:rPr lang="en-US" sz="2000" b="1" dirty="0">
                 <a:solidFill>
+                  <a:srgbClr val="F2F6FC"/>
+                </a:solidFill>
+                <a:latin typeface="Calibri" pitchFamily="34" charset="0"/>
+                <a:ea typeface="Calibri" pitchFamily="34" charset="-122"/>
+                <a:cs typeface="Calibri" pitchFamily="34" charset="-120"/>
+              </a:rPr>
+              <a:t>₹211 L → ₹138 L</a:t>
+            </a:r>
+            <a:endParaRPr lang="en-US" sz="2000" dirty="0"/>
+          </a:p>
+        </p:txBody>
+      </p:sp>
+      <p:sp>
+        <p:nvSpPr>
+          <p:cNvPr id="21" name="Text 18"/>
+          <p:cNvSpPr txBox="1"/>
+          <p:nvPr/>
+        </p:nvSpPr>
+        <p:spPr>
+          <a:xfrm>
+            <a:off x="5669280" y="3931920"/>
+            <a:ext cx="2926080" cy="457200"/>
+          </a:xfrm>
+          <a:prstGeom prst="rect">
+            <a:avLst/>
+          </a:prstGeom>
+          <a:noFill/>
+          <a:ln/>
+        </p:spPr>
+        <p:txBody>
+          <a:bodyPr wrap="square" lIns="0" tIns="0" rIns="0" bIns="0" rtlCol="0" anchor="t"/>
+          <a:lstStyle/>
+          <a:p>
+            <a:pPr marL="0" indent="0">
+              <a:buNone/>
+            </a:pPr>
+            <a:r>
+              <a:rPr lang="en-US" sz="1150" dirty="0">
+                <a:solidFill>
+                  <a:srgbClr val="A9BAD0"/>
+                </a:solidFill>
+                <a:latin typeface="Calibri" pitchFamily="34" charset="0"/>
+                <a:ea typeface="Calibri" pitchFamily="34" charset="-122"/>
+                <a:cs typeface="Calibri" pitchFamily="34" charset="-120"/>
+              </a:rPr>
+              <a:t>saves ≈ ₹73 L (35%), ≈ ₹53 L after a ₹20 L platform cost</a:t>
+            </a:r>
+            <a:endParaRPr lang="en-US" sz="1150" dirty="0"/>
+          </a:p>
+        </p:txBody>
+      </p:sp>
+      <p:sp>
+        <p:nvSpPr>
+          <p:cNvPr id="22" name="Text 19"/>
+          <p:cNvSpPr txBox="1"/>
+          <p:nvPr/>
+        </p:nvSpPr>
+        <p:spPr>
+          <a:xfrm>
+            <a:off x="457200" y="4572000"/>
+            <a:ext cx="8229600" cy="228600"/>
+          </a:xfrm>
+          <a:prstGeom prst="rect">
+            <a:avLst/>
+          </a:prstGeom>
+          <a:noFill/>
+          <a:ln/>
+        </p:spPr>
+        <p:txBody>
+          <a:bodyPr wrap="square" lIns="0" tIns="0" rIns="0" bIns="0" rtlCol="0" anchor="t"/>
+          <a:lstStyle/>
+          <a:p>
+            <a:pPr marL="0" indent="0">
+              <a:buNone/>
+            </a:pPr>
+            <a:r>
+              <a:rPr lang="en-US" sz="1100" b="1" dirty="0">
+                <a:solidFill>
                   <a:srgbClr val="F5A524"/>
                 </a:solidFill>
                 <a:latin typeface="Calibri" pitchFamily="34" charset="0"/>
                 <a:ea typeface="Calibri" pitchFamily="34" charset="-122"/>
                 <a:cs typeface="Calibri" pitchFamily="34" charset="-120"/>
               </a:rPr>
-              <a:t>₹73 L / yr</a:t>
-            </a:r>
-            <a:endParaRPr lang="en-US" sz="2000" dirty="0"/>
-          </a:p>
-        </p:txBody>
-      </p:sp>
-      <p:sp>
-        <p:nvSpPr>
-          <p:cNvPr id="5" name="Text 3"/>
-          <p:cNvSpPr txBox="1"/>
-          <p:nvPr/>
-        </p:nvSpPr>
-        <p:spPr>
-          <a:xfrm>
-            <a:off x="566928" y="1645920"/>
-            <a:ext cx="1783080" cy="411480"/>
-          </a:xfrm>
-          <a:prstGeom prst="rect">
-            <a:avLst/>
-          </a:prstGeom>
-          <a:noFill/>
-          <a:ln/>
-        </p:spPr>
-        <p:txBody>
-          <a:bodyPr wrap="square" lIns="0" tIns="0" rIns="0" bIns="0" rtlCol="0" anchor="t"/>
-          <a:lstStyle/>
-          <a:p>
-            <a:pPr marL="0" indent="0">
-              <a:buNone/>
-            </a:pPr>
-            <a:r>
-              <a:rPr lang="en-US" sz="1050" dirty="0">
-                <a:solidFill>
-                  <a:srgbClr val="A9BAD0"/>
-                </a:solidFill>
-                <a:latin typeface="Calibri" pitchFamily="34" charset="0"/>
-                <a:ea typeface="Calibri" pitchFamily="34" charset="-122"/>
-                <a:cs typeface="Calibri" pitchFamily="34" charset="-120"/>
-              </a:rPr>
-              <a:t>estimated benefit, base case</a:t>
-            </a:r>
-            <a:endParaRPr lang="en-US" sz="1050" dirty="0"/>
-          </a:p>
-        </p:txBody>
-      </p:sp>
-      <p:sp>
-        <p:nvSpPr>
-          <p:cNvPr id="6" name="Shape 4"/>
-          <p:cNvSpPr/>
-          <p:nvPr/>
-        </p:nvSpPr>
-        <p:spPr>
-          <a:xfrm>
-            <a:off x="2542032" y="1188720"/>
-            <a:ext cx="1965960" cy="914400"/>
-          </a:xfrm>
-          <a:prstGeom prst="roundRect">
-            <a:avLst>
-              <a:gd name="adj" fmla="val 8000"/>
-            </a:avLst>
-          </a:prstGeom>
-          <a:solidFill>
-            <a:srgbClr val="13243B"/>
-          </a:solidFill>
-          <a:ln w="9525">
-            <a:solidFill>
-              <a:srgbClr val="2A4466"/>
-            </a:solidFill>
-            <a:prstDash val="solid"/>
-          </a:ln>
-        </p:spPr>
-      </p:sp>
-      <p:sp>
-        <p:nvSpPr>
-          <p:cNvPr id="7" name="Text 5"/>
-          <p:cNvSpPr txBox="1"/>
-          <p:nvPr/>
-        </p:nvSpPr>
-        <p:spPr>
-          <a:xfrm>
-            <a:off x="2651760" y="1252728"/>
-            <a:ext cx="1783080" cy="384048"/>
-          </a:xfrm>
-          <a:prstGeom prst="rect">
-            <a:avLst/>
-          </a:prstGeom>
-          <a:noFill/>
-          <a:ln/>
-        </p:spPr>
-        <p:txBody>
-          <a:bodyPr wrap="square" lIns="0" tIns="0" rIns="0" bIns="0" rtlCol="0" anchor="t"/>
-          <a:lstStyle/>
-          <a:p>
-            <a:pPr marL="0" indent="0">
-              <a:buNone/>
-            </a:pPr>
-            <a:r>
-              <a:rPr lang="en-US" sz="2000" b="1" dirty="0">
-                <a:solidFill>
-                  <a:srgbClr val="F5A524"/>
-                </a:solidFill>
-                <a:latin typeface="Calibri" pitchFamily="34" charset="0"/>
-                <a:ea typeface="Calibri" pitchFamily="34" charset="-122"/>
-                <a:cs typeface="Calibri" pitchFamily="34" charset="-120"/>
-              </a:rPr>
-              <a:t>≈ 2170 h / yr</a:t>
-            </a:r>
-            <a:endParaRPr lang="en-US" sz="2000" dirty="0"/>
-          </a:p>
-        </p:txBody>
-      </p:sp>
-      <p:sp>
-        <p:nvSpPr>
-          <p:cNvPr id="8" name="Text 6"/>
-          <p:cNvSpPr txBox="1"/>
-          <p:nvPr/>
-        </p:nvSpPr>
-        <p:spPr>
-          <a:xfrm>
-            <a:off x="2651760" y="1645920"/>
-            <a:ext cx="1783080" cy="411480"/>
-          </a:xfrm>
-          <a:prstGeom prst="rect">
-            <a:avLst/>
-          </a:prstGeom>
-          <a:noFill/>
-          <a:ln/>
-        </p:spPr>
-        <p:txBody>
-          <a:bodyPr wrap="square" lIns="0" tIns="0" rIns="0" bIns="0" rtlCol="0" anchor="t"/>
-          <a:lstStyle/>
-          <a:p>
-            <a:pPr marL="0" indent="0">
-              <a:buNone/>
-            </a:pPr>
-            <a:r>
-              <a:rPr lang="en-US" sz="1050" dirty="0">
-                <a:solidFill>
-                  <a:srgbClr val="A9BAD0"/>
-                </a:solidFill>
-                <a:latin typeface="Calibri" pitchFamily="34" charset="0"/>
-                <a:ea typeface="Calibri" pitchFamily="34" charset="-122"/>
-                <a:cs typeface="Calibri" pitchFamily="34" charset="-120"/>
-              </a:rPr>
-              <a:t>engineer effort saved (about 1.2 full-time person)</a:t>
-            </a:r>
-            <a:endParaRPr lang="en-US" sz="1050" dirty="0"/>
-          </a:p>
-        </p:txBody>
-      </p:sp>
-      <p:sp>
-        <p:nvSpPr>
-          <p:cNvPr id="9" name="Shape 7"/>
-          <p:cNvSpPr/>
-          <p:nvPr/>
-        </p:nvSpPr>
-        <p:spPr>
-          <a:xfrm>
-            <a:off x="4626864" y="1188720"/>
-            <a:ext cx="1965960" cy="914400"/>
-          </a:xfrm>
-          <a:prstGeom prst="roundRect">
-            <a:avLst>
-              <a:gd name="adj" fmla="val 8000"/>
-            </a:avLst>
-          </a:prstGeom>
-          <a:solidFill>
-            <a:srgbClr val="13243B"/>
-          </a:solidFill>
-          <a:ln w="9525">
-            <a:solidFill>
-              <a:srgbClr val="2A4466"/>
-            </a:solidFill>
-            <a:prstDash val="solid"/>
-          </a:ln>
-        </p:spPr>
-      </p:sp>
-      <p:sp>
-        <p:nvSpPr>
-          <p:cNvPr id="10" name="Text 8"/>
-          <p:cNvSpPr txBox="1"/>
-          <p:nvPr/>
-        </p:nvSpPr>
-        <p:spPr>
-          <a:xfrm>
-            <a:off x="4736592" y="1252728"/>
-            <a:ext cx="1783080" cy="384048"/>
-          </a:xfrm>
-          <a:prstGeom prst="rect">
-            <a:avLst/>
-          </a:prstGeom>
-          <a:noFill/>
-          <a:ln/>
-        </p:spPr>
-        <p:txBody>
-          <a:bodyPr wrap="square" lIns="0" tIns="0" rIns="0" bIns="0" rtlCol="0" anchor="t"/>
-          <a:lstStyle/>
-          <a:p>
-            <a:pPr marL="0" indent="0">
-              <a:buNone/>
-            </a:pPr>
-            <a:r>
-              <a:rPr lang="en-US" sz="2000" b="1" dirty="0">
-                <a:solidFill>
-                  <a:srgbClr val="F5A524"/>
-                </a:solidFill>
-                <a:latin typeface="Calibri" pitchFamily="34" charset="0"/>
-                <a:ea typeface="Calibri" pitchFamily="34" charset="-122"/>
-                <a:cs typeface="Calibri" pitchFamily="34" charset="-120"/>
-              </a:rPr>
-              <a:t>≈ 6 months</a:t>
-            </a:r>
-            <a:endParaRPr lang="en-US" sz="2000" dirty="0"/>
-          </a:p>
-        </p:txBody>
-      </p:sp>
-      <p:sp>
-        <p:nvSpPr>
-          <p:cNvPr id="11" name="Text 9"/>
-          <p:cNvSpPr txBox="1"/>
-          <p:nvPr/>
-        </p:nvSpPr>
-        <p:spPr>
-          <a:xfrm>
-            <a:off x="4736592" y="1645920"/>
-            <a:ext cx="1783080" cy="411480"/>
-          </a:xfrm>
-          <a:prstGeom prst="rect">
-            <a:avLst/>
-          </a:prstGeom>
-          <a:noFill/>
-          <a:ln/>
-        </p:spPr>
-        <p:txBody>
-          <a:bodyPr wrap="square" lIns="0" tIns="0" rIns="0" bIns="0" rtlCol="0" anchor="t"/>
-          <a:lstStyle/>
-          <a:p>
-            <a:pPr marL="0" indent="0">
-              <a:buNone/>
-            </a:pPr>
-            <a:r>
-              <a:rPr lang="en-US" sz="1050" dirty="0">
-                <a:solidFill>
-                  <a:srgbClr val="A9BAD0"/>
-                </a:solidFill>
-                <a:latin typeface="Calibri" pitchFamily="34" charset="0"/>
-                <a:ea typeface="Calibri" pitchFamily="34" charset="-122"/>
-                <a:cs typeface="Calibri" pitchFamily="34" charset="-120"/>
-              </a:rPr>
-              <a:t>payback on ₹25 L setup</a:t>
-            </a:r>
-            <a:endParaRPr lang="en-US" sz="1050" dirty="0"/>
-          </a:p>
-        </p:txBody>
-      </p:sp>
-      <p:sp>
-        <p:nvSpPr>
-          <p:cNvPr id="12" name="Shape 10"/>
-          <p:cNvSpPr/>
-          <p:nvPr/>
-        </p:nvSpPr>
-        <p:spPr>
-          <a:xfrm>
-            <a:off x="6711696" y="1188720"/>
-            <a:ext cx="1965960" cy="914400"/>
-          </a:xfrm>
-          <a:prstGeom prst="roundRect">
-            <a:avLst>
-              <a:gd name="adj" fmla="val 8000"/>
-            </a:avLst>
-          </a:prstGeom>
-          <a:solidFill>
-            <a:srgbClr val="13243B"/>
-          </a:solidFill>
-          <a:ln w="9525">
-            <a:solidFill>
-              <a:srgbClr val="2A4466"/>
-            </a:solidFill>
-            <a:prstDash val="solid"/>
-          </a:ln>
-        </p:spPr>
-      </p:sp>
-      <p:sp>
-        <p:nvSpPr>
-          <p:cNvPr id="13" name="Text 11"/>
-          <p:cNvSpPr txBox="1"/>
-          <p:nvPr/>
-        </p:nvSpPr>
-        <p:spPr>
-          <a:xfrm>
-            <a:off x="6821424" y="1252728"/>
-            <a:ext cx="1783080" cy="384048"/>
-          </a:xfrm>
-          <a:prstGeom prst="rect">
-            <a:avLst/>
-          </a:prstGeom>
-          <a:noFill/>
-          <a:ln/>
-        </p:spPr>
-        <p:txBody>
-          <a:bodyPr wrap="square" lIns="0" tIns="0" rIns="0" bIns="0" rtlCol="0" anchor="t"/>
-          <a:lstStyle/>
-          <a:p>
-            <a:pPr marL="0" indent="0">
-              <a:buNone/>
-            </a:pPr>
-            <a:r>
-              <a:rPr lang="en-US" sz="2000" b="1" dirty="0">
-                <a:solidFill>
-                  <a:srgbClr val="F5A524"/>
-                </a:solidFill>
-                <a:latin typeface="Calibri" pitchFamily="34" charset="0"/>
-                <a:ea typeface="Calibri" pitchFamily="34" charset="-122"/>
-                <a:cs typeface="Calibri" pitchFamily="34" charset="-120"/>
-              </a:rPr>
-              <a:t>₹1.35 cr</a:t>
-            </a:r>
-            <a:endParaRPr lang="en-US" sz="2000" dirty="0"/>
-          </a:p>
-        </p:txBody>
-      </p:sp>
-      <p:sp>
-        <p:nvSpPr>
-          <p:cNvPr id="14" name="Text 12"/>
-          <p:cNvSpPr txBox="1"/>
-          <p:nvPr/>
-        </p:nvSpPr>
-        <p:spPr>
-          <a:xfrm>
-            <a:off x="6821424" y="1645920"/>
-            <a:ext cx="1783080" cy="411480"/>
-          </a:xfrm>
-          <a:prstGeom prst="rect">
-            <a:avLst/>
-          </a:prstGeom>
-          <a:noFill/>
-          <a:ln/>
-        </p:spPr>
-        <p:txBody>
-          <a:bodyPr wrap="square" lIns="0" tIns="0" rIns="0" bIns="0" rtlCol="0" anchor="t"/>
-          <a:lstStyle/>
-          <a:p>
-            <a:pPr marL="0" indent="0">
-              <a:buNone/>
-            </a:pPr>
-            <a:r>
-              <a:rPr lang="en-US" sz="1050" dirty="0">
-                <a:solidFill>
-                  <a:srgbClr val="A9BAD0"/>
-                </a:solidFill>
-                <a:latin typeface="Calibri" pitchFamily="34" charset="0"/>
-                <a:ea typeface="Calibri" pitchFamily="34" charset="-122"/>
-                <a:cs typeface="Calibri" pitchFamily="34" charset="-120"/>
-              </a:rPr>
-              <a:t>net benefit over 3 years</a:t>
-            </a:r>
-            <a:endParaRPr lang="en-US" sz="1050" dirty="0"/>
-          </a:p>
-        </p:txBody>
-      </p:sp>
-      <p:graphicFrame>
-        <p:nvGraphicFramePr>
-          <p:cNvPr id="15" name="Chart 0"/>
-          <p:cNvGraphicFramePr/>
-          <p:nvPr/>
-        </p:nvGraphicFramePr>
-        <p:xfrm>
-          <a:off x="365760" y="2240280"/>
-          <a:ext cx="4937760" cy="2286000"/>
-        </p:xfrm>
-        <a:graphic>
-          <a:graphicData uri="http://schemas.openxmlformats.org/drawingml/2006/chart">
-            <c:chart xmlns:c="http://schemas.openxmlformats.org/drawingml/2006/chart" xmlns:r="http://schemas.openxmlformats.org/officeDocument/2006/relationships" r:id="rId3"/>
-          </a:graphicData>
-        </a:graphic>
-      </p:graphicFrame>
-      <p:sp>
-        <p:nvSpPr>
-          <p:cNvPr id="16" name="Shape 13"/>
-          <p:cNvSpPr/>
-          <p:nvPr/>
-        </p:nvSpPr>
-        <p:spPr>
-          <a:xfrm>
-            <a:off x="5440680" y="2240280"/>
-            <a:ext cx="3246120" cy="2286000"/>
-          </a:xfrm>
-          <a:prstGeom prst="roundRect">
-            <a:avLst>
-              <a:gd name="adj" fmla="val 3200"/>
-            </a:avLst>
-          </a:prstGeom>
-          <a:solidFill>
-            <a:srgbClr val="13243B"/>
-          </a:solidFill>
-          <a:ln w="9525">
-            <a:solidFill>
-              <a:srgbClr val="2A4466"/>
-            </a:solidFill>
-            <a:prstDash val="solid"/>
-          </a:ln>
-        </p:spPr>
-      </p:sp>
-      <p:sp>
-        <p:nvSpPr>
-          <p:cNvPr id="17" name="Text 14"/>
-          <p:cNvSpPr txBox="1"/>
-          <p:nvPr/>
-        </p:nvSpPr>
-        <p:spPr>
-          <a:xfrm>
-            <a:off x="5577840" y="2313432"/>
-            <a:ext cx="3017520" cy="228600"/>
-          </a:xfrm>
-          <a:prstGeom prst="rect">
-            <a:avLst/>
-          </a:prstGeom>
-          <a:noFill/>
-          <a:ln/>
-        </p:spPr>
-        <p:txBody>
-          <a:bodyPr wrap="square" lIns="0" tIns="0" rIns="0" bIns="0" rtlCol="0" anchor="t"/>
-          <a:lstStyle/>
-          <a:p>
-            <a:pPr marL="0" indent="0">
-              <a:buNone/>
-            </a:pPr>
-            <a:r>
-              <a:rPr lang="en-US" sz="1000" b="1" kern="0" spc="100" dirty="0">
-                <a:solidFill>
-                  <a:srgbClr val="F5A524"/>
-                </a:solidFill>
-                <a:latin typeface="Calibri" pitchFamily="34" charset="0"/>
-                <a:ea typeface="Calibri" pitchFamily="34" charset="-122"/>
-                <a:cs typeface="Calibri" pitchFamily="34" charset="-120"/>
-              </a:rPr>
-              <a:t>KEY ASSUMPTIONS (10-structure network)</a:t>
-            </a:r>
-            <a:endParaRPr lang="en-US" sz="1000" dirty="0"/>
-          </a:p>
-        </p:txBody>
-      </p:sp>
-      <p:sp>
-        <p:nvSpPr>
-          <p:cNvPr id="18" name="Text 15"/>
-          <p:cNvSpPr txBox="1"/>
-          <p:nvPr/>
-        </p:nvSpPr>
-        <p:spPr>
-          <a:xfrm>
-            <a:off x="5577840" y="2578608"/>
-            <a:ext cx="3017520" cy="1920240"/>
-          </a:xfrm>
-          <a:prstGeom prst="rect">
-            <a:avLst/>
-          </a:prstGeom>
-          <a:noFill/>
-          <a:ln/>
-        </p:spPr>
-        <p:txBody>
-          <a:bodyPr wrap="square" lIns="0" tIns="0" rIns="0" bIns="0" rtlCol="0" anchor="t"/>
-          <a:lstStyle/>
-          <a:p>
-            <a:pPr marL="342900" indent="-342900">
-              <a:spcAft>
-                <a:spcPts val="400"/>
-              </a:spcAft>
-              <a:buSzPct val="100000"/>
-              <a:buChar char="•"/>
-            </a:pPr>
-            <a:r>
-              <a:rPr lang="en-US" sz="1100" dirty="0">
-                <a:solidFill>
-                  <a:srgbClr val="F2F6FC"/>
-                </a:solidFill>
-                <a:latin typeface="Calibri" pitchFamily="34" charset="0"/>
-                <a:ea typeface="Calibri" pitchFamily="34" charset="-122"/>
-                <a:cs typeface="Calibri" pitchFamily="34" charset="-120"/>
-              </a:rPr>
-              <a:t>40 alerts a month, 6 h manual triage each, 60% saved</a:t>
+              <a:t>Range: conservative ≈ ₹37 L a year, optimistic ≈ ₹95 L. Illustrative assumptions, not measured savings; a pilot replaces them.</a:t>
             </a:r>
             <a:endParaRPr lang="en-US" sz="1100" dirty="0"/>
-          </a:p>
-          <a:p>
-            <a:pPr marL="342900" indent="-342900">
-              <a:spcAft>
-                <a:spcPts val="400"/>
-              </a:spcAft>
-              <a:buSzPct val="100000"/>
-              <a:buChar char="•"/>
-            </a:pPr>
-            <a:r>
-              <a:rPr lang="en-US" sz="1100" dirty="0">
-                <a:solidFill>
-                  <a:srgbClr val="F2F6FC"/>
-                </a:solidFill>
-                <a:latin typeface="Calibri" pitchFamily="34" charset="0"/>
-                <a:ea typeface="Calibri" pitchFamily="34" charset="-122"/>
-                <a:cs typeface="Calibri" pitchFamily="34" charset="-120"/>
-              </a:rPr>
-              <a:t>8 needless callouts a month at ₹25,000; half avoided</a:t>
-            </a:r>
-            <a:endParaRPr lang="en-US" sz="1100" dirty="0"/>
-          </a:p>
-          <a:p>
-            <a:pPr marL="342900" indent="-342900">
-              <a:spcAft>
-                <a:spcPts val="400"/>
-              </a:spcAft>
-              <a:buSzPct val="100000"/>
-              <a:buChar char="•"/>
-            </a:pPr>
-            <a:r>
-              <a:rPr lang="en-US" sz="1100" dirty="0">
-                <a:solidFill>
-                  <a:srgbClr val="F2F6FC"/>
-                </a:solidFill>
-                <a:latin typeface="Calibri" pitchFamily="34" charset="0"/>
-                <a:ea typeface="Calibri" pitchFamily="34" charset="-122"/>
-                <a:cs typeface="Calibri" pitchFamily="34" charset="-120"/>
-              </a:rPr>
-              <a:t>4 unplanned closures a year, 36 h at ₹60,000 per hour; a quarter avoided</a:t>
-            </a:r>
-            <a:endParaRPr lang="en-US" sz="1100" dirty="0"/>
-          </a:p>
-          <a:p>
-            <a:pPr marL="342900" indent="-342900">
-              <a:spcAft>
-                <a:spcPts val="400"/>
-              </a:spcAft>
-              <a:buSzPct val="100000"/>
-              <a:buChar char="•"/>
-            </a:pPr>
-            <a:r>
-              <a:rPr lang="en-US" sz="1100" dirty="0">
-                <a:solidFill>
-                  <a:srgbClr val="F2F6FC"/>
-                </a:solidFill>
-                <a:latin typeface="Calibri" pitchFamily="34" charset="0"/>
-                <a:ea typeface="Calibri" pitchFamily="34" charset="-122"/>
-                <a:cs typeface="Calibri" pitchFamily="34" charset="-120"/>
-              </a:rPr>
-              <a:t>Engineer cost ₹1,500 per hour; platform ₹20 L a year; setup ₹25 L</a:t>
-            </a:r>
-            <a:endParaRPr lang="en-US" sz="1100" dirty="0"/>
-          </a:p>
-        </p:txBody>
-      </p:sp>
-      <p:sp>
-        <p:nvSpPr>
-          <p:cNvPr id="19" name="Text 16"/>
-          <p:cNvSpPr txBox="1"/>
-          <p:nvPr/>
-        </p:nvSpPr>
-        <p:spPr>
-          <a:xfrm>
-            <a:off x="457200" y="4544568"/>
-            <a:ext cx="8229600" cy="274320"/>
-          </a:xfrm>
-          <a:prstGeom prst="rect">
-            <a:avLst/>
-          </a:prstGeom>
-          <a:noFill/>
-          <a:ln/>
-        </p:spPr>
-        <p:txBody>
-          <a:bodyPr wrap="square" lIns="0" tIns="0" rIns="0" bIns="0" rtlCol="0" anchor="t"/>
-          <a:lstStyle/>
-          <a:p>
-            <a:pPr marL="0" indent="0">
-              <a:buNone/>
-            </a:pPr>
-            <a:r>
-              <a:rPr lang="en-US" sz="1050" b="1" dirty="0">
-                <a:solidFill>
-                  <a:srgbClr val="F5A524"/>
-                </a:solidFill>
-                <a:latin typeface="Calibri" pitchFamily="34" charset="0"/>
-                <a:ea typeface="Calibri" pitchFamily="34" charset="-122"/>
-                <a:cs typeface="Calibri" pitchFamily="34" charset="-120"/>
-              </a:rPr>
-              <a:t>Range: conservative (half the effect) ₹37 L a year, payback ≈ 18 months  ·  optimistic ₹95 L a year, payback ≈ 4 months. Illustrative, not measured.</a:t>
-            </a:r>
-            <a:endParaRPr lang="en-US" sz="1050" dirty="0"/>
           </a:p>
         </p:txBody>
       </p:sp>

</xml_diff>